<commit_message>
update PPTX with new number of tests
</commit_message>
<xml_diff>
--- a/BottleNeck_Pipeline.pptx
+++ b/BottleNeck_Pipeline.pptx
@@ -3793,7 +3793,7 @@
                   <a:srgbClr val="FFFFFF"/>
                 </a:solidFill>
               </a:rPr>
-              <a:t>Lancer les 41 tests pytest</a:t>
+              <a:t>Lancer les 39 tests pytest</a:t>
             </a:r>
             <a:endParaRPr lang="en-US" sz="1100" dirty="0"/>
           </a:p>
@@ -3900,7 +3900,7 @@
                   <a:srgbClr val="A0A0B8"/>
                 </a:solidFill>
               </a:rPr>
-              <a:t>Montrer les 41 tests PASSED — dont les 11 tests cibles qui valident les chiffres de Stéphane</a:t>
+              <a:t>Montrer les 39 tests PASSED — dont les 11 tests cibles qui valident les chiffres de Stéphane</a:t>
             </a:r>
             <a:endParaRPr lang="en-US" sz="850" dirty="0"/>
           </a:p>
@@ -5893,7 +5893,7 @@
                   <a:srgbClr val="0D9488"/>
                 </a:solidFill>
               </a:rPr>
-              <a:t>41</a:t>
+              <a:t>39</a:t>
             </a:r>
             <a:endParaRPr lang="en-US" sz="2400" dirty="0"/>
           </a:p>
@@ -5943,7 +5943,7 @@
                   <a:srgbClr val="555577"/>
                 </a:solidFill>
               </a:rPr>
-              <a:t>validés (41/41 ✅)</a:t>
+              <a:t>validés (39/39 ✅)</a:t>
             </a:r>
             <a:endParaRPr lang="en-US" sz="950" dirty="0"/>
           </a:p>
@@ -6276,7 +6276,7 @@
                   <a:srgbClr val="FFFFFF"/>
                 </a:solidFill>
               </a:rPr>
-              <a:t>🧪  41 tests pytest validés</a:t>
+              <a:t>🧪  39 tests pytest validés</a:t>
             </a:r>
             <a:endParaRPr lang="en-US" sz="950" dirty="0"/>
           </a:p>
@@ -6312,7 +6312,7 @@
                   <a:srgbClr val="A0A0B8"/>
                 </a:solidFill>
               </a:rPr>
-              <a:t>25 unitaires + 5 intégration + 11 cibles — exécutables en continu</a:t>
+              <a:t>23 unitaires + 5 intégration + 11 cibles — exécutables en continu</a:t>
             </a:r>
             <a:endParaRPr lang="en-US" sz="850" dirty="0"/>
           </a:p>
@@ -7711,7 +7711,7 @@
                   <a:srgbClr val="A0A0B8"/>
                 </a:solidFill>
               </a:rPr>
-              <a:t>Exécuter automatiquement les 41 tests pytest à chaque push sur le repo pour éviter les régressions lors de modifications des scripts Python / SQL.</a:t>
+              <a:t>Exécuter automatiquement les 39 tests pytest à chaque push sur le repo pour éviter les régressions lors de modifications des scripts Python / SQL.</a:t>
             </a:r>
             <a:endParaRPr lang="en-US" sz="900" dirty="0"/>
           </a:p>
@@ -8153,7 +8153,7 @@
                   <a:srgbClr val="E8E8F0"/>
                 </a:solidFill>
               </a:rPr>
-              <a:t>🧪  41 tests pytest garantissant la qualité à chaque étape</a:t>
+              <a:t>🧪  39 tests pytest garantissant la qualité à chaque étape</a:t>
             </a:r>
             <a:endParaRPr lang="en-US" sz="1100" dirty="0"/>
           </a:p>
@@ -9312,7 +9312,7 @@
                   <a:srgbClr val="A0A0B8"/>
                 </a:solidFill>
               </a:rPr>
-              <a:t>41 tests, chiffres de référence</a:t>
+              <a:t>39 tests, chiffres de référence</a:t>
             </a:r>
             <a:endParaRPr lang="en-US" sz="950" dirty="0"/>
           </a:p>
@@ -11802,7 +11802,7 @@
                   <a:srgbClr val="FFFFFF"/>
                 </a:solidFill>
               </a:rPr>
-              <a:t>✅  pytest (41 tests)</a:t>
+              <a:t>✅  pytest (39 tests)</a:t>
             </a:r>
             <a:endParaRPr lang="en-US" sz="1100" dirty="0"/>
           </a:p>
@@ -16471,7 +16471,7 @@
                   <a:srgbClr val="FFFFFF"/>
                 </a:solidFill>
               </a:rPr>
-              <a:t>06  |  Tests &amp; qualité des données — 41 tests pytest</a:t>
+              <a:t>06  |  Tests &amp; qualité des données — 39 tests pytest</a:t>
             </a:r>
             <a:endParaRPr lang="en-US" sz="2000" dirty="0"/>
           </a:p>
@@ -16507,7 +16507,7 @@
                   <a:srgbClr val="A0A0B8"/>
                 </a:solidFill>
               </a:rPr>
-              <a:t>41 tests pytest : 25 unitaires + 5 intégration + 11 cibles + tests SQL inline dans Kestra.</a:t>
+              <a:t>39 tests pytest : 23 unitaires + 5 intégration + 11 cibles + tests SQL inline dans Kestra.</a:t>
             </a:r>
             <a:endParaRPr lang="en-US" sz="1050" dirty="0"/>
           </a:p>

</xml_diff>